<commit_message>
Add study workflow diagram slide
</commit_message>
<xml_diff>
--- a/noninvasive_hc_ec_literature_review.pptx
+++ b/noninvasive_hc_ec_literature_review.pptx
@@ -11,6 +11,7 @@
     <p:sldId id="259" r:id="rId10"/>
     <p:sldId id="260" r:id="rId11"/>
     <p:sldId id="261" r:id="rId12"/>
+    <p:sldId id="262" r:id="rId13"/>
   </p:sldIdLst>
   <p:sldSz cx="12191695" cy="6858000" type="screen4x3"/>
   <p:notesSz cx="6858000" cy="9144000"/>
@@ -7145,6 +7146,981 @@
             </a:pPr>
             <a:r>
               <a:t>一句话 takeaway：非侵入性深部刺激不仅能“碰到”HC–EC，还能改变空间记忆行为；但临床应用仍需验证。</a:t>
+            </a:r>
+          </a:p>
+        </p:txBody>
+      </p:sp>
+    </p:spTree>
+  </p:cSld>
+  <p:clrMapOvr>
+    <a:masterClrMapping/>
+  </p:clrMapOvr>
+</p:sld>
+</file>
+
+<file path=ppt/slides/slide7.xml><?xml version="1.0" encoding="utf-8"?>
+<p:sld xmlns:a="http://schemas.openxmlformats.org/drawingml/2006/main" xmlns:p="http://schemas.openxmlformats.org/presentationml/2006/main" xmlns:r="http://schemas.openxmlformats.org/officeDocument/2006/relationships">
+  <p:cSld>
+    <p:bg>
+      <p:bgPr>
+        <a:solidFill>
+          <a:srgbClr val="F7F9FC"/>
+        </a:solidFill>
+        <a:effectLst/>
+      </p:bgPr>
+    </p:bg>
+    <p:spTree>
+      <p:nvGrpSpPr>
+        <p:cNvPr id="1" name=""/>
+        <p:cNvGrpSpPr/>
+        <p:nvPr/>
+      </p:nvGrpSpPr>
+      <p:grpSpPr/>
+      <p:sp>
+        <p:nvSpPr>
+          <p:cNvPr id="2" name="Rectangle 1"/>
+          <p:cNvSpPr/>
+          <p:nvPr/>
+        </p:nvSpPr>
+        <p:spPr>
+          <a:xfrm>
+            <a:off x="0" y="0"/>
+            <a:ext cx="12191695" cy="841248"/>
+          </a:xfrm>
+          <a:prstGeom prst="rect">
+            <a:avLst/>
+          </a:prstGeom>
+          <a:solidFill>
+            <a:srgbClr val="142B4B"/>
+          </a:solidFill>
+          <a:ln>
+            <a:noFill/>
+          </a:ln>
+        </p:spPr>
+        <p:style>
+          <a:lnRef idx="1">
+            <a:schemeClr val="accent1"/>
+          </a:lnRef>
+          <a:fillRef idx="3">
+            <a:schemeClr val="accent1"/>
+          </a:fillRef>
+          <a:effectRef idx="2">
+            <a:schemeClr val="accent1"/>
+          </a:effectRef>
+          <a:fontRef idx="minor">
+            <a:schemeClr val="lt1"/>
+          </a:fontRef>
+        </p:style>
+        <p:txBody>
+          <a:bodyPr rtlCol="0" anchor="ctr"/>
+          <a:lstStyle/>
+          <a:p>
+            <a:pPr algn="ctr"/>
+          </a:p>
+        </p:txBody>
+      </p:sp>
+      <p:sp>
+        <p:nvSpPr>
+          <p:cNvPr id="3" name="TextBox 2"/>
+          <p:cNvSpPr txBox="1"/>
+          <p:nvPr/>
+        </p:nvSpPr>
+        <p:spPr>
+          <a:xfrm>
+            <a:off x="594360" y="155448"/>
+            <a:ext cx="10515600" cy="329184"/>
+          </a:xfrm>
+          <a:prstGeom prst="rect">
+            <a:avLst/>
+          </a:prstGeom>
+          <a:noFill/>
+        </p:spPr>
+        <p:txBody>
+          <a:bodyPr wrap="none" lIns="0" rIns="0" tIns="0" bIns="0" anchor="ctr">
+            <a:spAutoFit/>
+          </a:bodyPr>
+          <a:lstStyle/>
+          <a:p>
+            <a:pPr>
+              <a:defRPr sz="2400" b="1">
+                <a:solidFill>
+                  <a:srgbClr val="FFFFFF"/>
+                </a:solidFill>
+                <a:latin typeface="Microsoft YaHei"/>
+              </a:defRPr>
+            </a:pPr>
+            <a:r>
+              <a:t>研究流程图：从深部刺激到空间导航结果</a:t>
+            </a:r>
+          </a:p>
+        </p:txBody>
+      </p:sp>
+      <p:sp>
+        <p:nvSpPr>
+          <p:cNvPr id="4" name="TextBox 3"/>
+          <p:cNvSpPr txBox="1"/>
+          <p:nvPr/>
+        </p:nvSpPr>
+        <p:spPr>
+          <a:xfrm>
+            <a:off x="594360" y="585216"/>
+            <a:ext cx="4572000" cy="164592"/>
+          </a:xfrm>
+          <a:prstGeom prst="rect">
+            <a:avLst/>
+          </a:prstGeom>
+          <a:noFill/>
+        </p:spPr>
+        <p:txBody>
+          <a:bodyPr wrap="none" lIns="0" rIns="0" tIns="0" bIns="0" anchor="ctr">
+            <a:spAutoFit/>
+          </a:bodyPr>
+          <a:lstStyle/>
+          <a:p>
+            <a:pPr>
+              <a:defRPr sz="900" b="0">
+                <a:solidFill>
+                  <a:srgbClr val="BCCFE2"/>
+                </a:solidFill>
+                <a:latin typeface="Microsoft YaHei"/>
+              </a:defRPr>
+            </a:pPr>
+            <a:r>
+              <a:t>STUDY WORKFLOW</a:t>
+            </a:r>
+          </a:p>
+        </p:txBody>
+      </p:sp>
+      <p:sp>
+        <p:nvSpPr>
+          <p:cNvPr id="5" name="Rounded Rectangle 4"/>
+          <p:cNvSpPr/>
+          <p:nvPr/>
+        </p:nvSpPr>
+        <p:spPr>
+          <a:xfrm>
+            <a:off x="502920" y="1965960"/>
+            <a:ext cx="1965960" cy="2057400"/>
+          </a:xfrm>
+          <a:prstGeom prst="roundRect">
+            <a:avLst/>
+          </a:prstGeom>
+          <a:solidFill>
+            <a:srgbClr val="FFFFFF"/>
+          </a:solidFill>
+          <a:ln w="25400">
+            <a:solidFill>
+              <a:srgbClr val="2A6EB4"/>
+            </a:solidFill>
+          </a:ln>
+        </p:spPr>
+        <p:style>
+          <a:lnRef idx="1">
+            <a:schemeClr val="accent1"/>
+          </a:lnRef>
+          <a:fillRef idx="3">
+            <a:schemeClr val="accent1"/>
+          </a:fillRef>
+          <a:effectRef idx="2">
+            <a:schemeClr val="accent1"/>
+          </a:effectRef>
+          <a:fontRef idx="minor">
+            <a:schemeClr val="lt1"/>
+          </a:fontRef>
+        </p:style>
+        <p:txBody>
+          <a:bodyPr rtlCol="0" anchor="ctr"/>
+          <a:lstStyle/>
+          <a:p>
+            <a:pPr algn="ctr"/>
+          </a:p>
+        </p:txBody>
+      </p:sp>
+      <p:sp>
+        <p:nvSpPr>
+          <p:cNvPr id="6" name="TextBox 5"/>
+          <p:cNvSpPr txBox="1"/>
+          <p:nvPr/>
+        </p:nvSpPr>
+        <p:spPr>
+          <a:xfrm>
+            <a:off x="612648" y="2176272"/>
+            <a:ext cx="1737360" cy="347472"/>
+          </a:xfrm>
+          <a:prstGeom prst="rect">
+            <a:avLst/>
+          </a:prstGeom>
+          <a:noFill/>
+        </p:spPr>
+        <p:txBody>
+          <a:bodyPr wrap="none" lIns="0" rIns="0" tIns="0" bIns="0" anchor="ctr">
+            <a:spAutoFit/>
+          </a:bodyPr>
+          <a:lstStyle/>
+          <a:p>
+            <a:pPr algn="ctr">
+              <a:defRPr sz="1500" b="1">
+                <a:solidFill>
+                  <a:srgbClr val="2A6EB4"/>
+                </a:solidFill>
+                <a:latin typeface="Microsoft YaHei"/>
+              </a:defRPr>
+            </a:pPr>
+            <a:r>
+              <a:t>① 受试者</a:t>
+            </a:r>
+          </a:p>
+        </p:txBody>
+      </p:sp>
+      <p:sp>
+        <p:nvSpPr>
+          <p:cNvPr id="7" name="TextBox 6"/>
+          <p:cNvSpPr txBox="1"/>
+          <p:nvPr/>
+        </p:nvSpPr>
+        <p:spPr>
+          <a:xfrm>
+            <a:off x="612648" y="2788920"/>
+            <a:ext cx="1737360" cy="868680"/>
+          </a:xfrm>
+          <a:prstGeom prst="rect">
+            <a:avLst/>
+          </a:prstGeom>
+          <a:noFill/>
+        </p:spPr>
+        <p:txBody>
+          <a:bodyPr wrap="none" lIns="0" rIns="0" tIns="0" bIns="0" anchor="ctr">
+            <a:spAutoFit/>
+          </a:bodyPr>
+          <a:lstStyle/>
+          <a:p>
+            <a:pPr algn="ctr">
+              <a:defRPr sz="1400" b="0">
+                <a:solidFill>
+                  <a:srgbClr val="263444"/>
+                </a:solidFill>
+                <a:latin typeface="Microsoft YaHei"/>
+              </a:defRPr>
+            </a:pPr>
+            <a:r>
+              <a:t>健康志愿者</a:t>
+            </a:r>
+            <a:br/>
+            <a:r>
+              <a:t>N = 30</a:t>
+            </a:r>
+          </a:p>
+        </p:txBody>
+      </p:sp>
+      <p:sp>
+        <p:nvSpPr>
+          <p:cNvPr id="8" name="TextBox 7"/>
+          <p:cNvSpPr txBox="1"/>
+          <p:nvPr/>
+        </p:nvSpPr>
+        <p:spPr>
+          <a:xfrm>
+            <a:off x="2505456" y="2724912"/>
+            <a:ext cx="365760" cy="320040"/>
+          </a:xfrm>
+          <a:prstGeom prst="rect">
+            <a:avLst/>
+          </a:prstGeom>
+          <a:noFill/>
+        </p:spPr>
+        <p:txBody>
+          <a:bodyPr wrap="none" lIns="0" rIns="0" tIns="0" bIns="0" anchor="ctr">
+            <a:spAutoFit/>
+          </a:bodyPr>
+          <a:lstStyle/>
+          <a:p>
+            <a:pPr algn="ctr">
+              <a:defRPr sz="2400" b="1">
+                <a:solidFill>
+                  <a:srgbClr val="5F7082"/>
+                </a:solidFill>
+                <a:latin typeface="Microsoft YaHei"/>
+              </a:defRPr>
+            </a:pPr>
+            <a:r>
+              <a:t>→</a:t>
+            </a:r>
+          </a:p>
+        </p:txBody>
+      </p:sp>
+      <p:sp>
+        <p:nvSpPr>
+          <p:cNvPr id="9" name="Rounded Rectangle 8"/>
+          <p:cNvSpPr/>
+          <p:nvPr/>
+        </p:nvSpPr>
+        <p:spPr>
+          <a:xfrm>
+            <a:off x="2862072" y="1965960"/>
+            <a:ext cx="1965960" cy="2057400"/>
+          </a:xfrm>
+          <a:prstGeom prst="roundRect">
+            <a:avLst/>
+          </a:prstGeom>
+          <a:solidFill>
+            <a:srgbClr val="FFFFFF"/>
+          </a:solidFill>
+          <a:ln w="25400">
+            <a:solidFill>
+              <a:srgbClr val="249691"/>
+            </a:solidFill>
+          </a:ln>
+        </p:spPr>
+        <p:style>
+          <a:lnRef idx="1">
+            <a:schemeClr val="accent1"/>
+          </a:lnRef>
+          <a:fillRef idx="3">
+            <a:schemeClr val="accent1"/>
+          </a:fillRef>
+          <a:effectRef idx="2">
+            <a:schemeClr val="accent1"/>
+          </a:effectRef>
+          <a:fontRef idx="minor">
+            <a:schemeClr val="lt1"/>
+          </a:fontRef>
+        </p:style>
+        <p:txBody>
+          <a:bodyPr rtlCol="0" anchor="ctr"/>
+          <a:lstStyle/>
+          <a:p>
+            <a:pPr algn="ctr"/>
+          </a:p>
+        </p:txBody>
+      </p:sp>
+      <p:sp>
+        <p:nvSpPr>
+          <p:cNvPr id="10" name="TextBox 9"/>
+          <p:cNvSpPr txBox="1"/>
+          <p:nvPr/>
+        </p:nvSpPr>
+        <p:spPr>
+          <a:xfrm>
+            <a:off x="2971800" y="2176272"/>
+            <a:ext cx="1737360" cy="347472"/>
+          </a:xfrm>
+          <a:prstGeom prst="rect">
+            <a:avLst/>
+          </a:prstGeom>
+          <a:noFill/>
+        </p:spPr>
+        <p:txBody>
+          <a:bodyPr wrap="none" lIns="0" rIns="0" tIns="0" bIns="0" anchor="ctr">
+            <a:spAutoFit/>
+          </a:bodyPr>
+          <a:lstStyle/>
+          <a:p>
+            <a:pPr algn="ctr">
+              <a:defRPr sz="1500" b="1">
+                <a:solidFill>
+                  <a:srgbClr val="249691"/>
+                </a:solidFill>
+                <a:latin typeface="Microsoft YaHei"/>
+              </a:defRPr>
+            </a:pPr>
+            <a:r>
+              <a:t>② 刺激</a:t>
+            </a:r>
+          </a:p>
+        </p:txBody>
+      </p:sp>
+      <p:sp>
+        <p:nvSpPr>
+          <p:cNvPr id="11" name="TextBox 10"/>
+          <p:cNvSpPr txBox="1"/>
+          <p:nvPr/>
+        </p:nvSpPr>
+        <p:spPr>
+          <a:xfrm>
+            <a:off x="2971800" y="2788920"/>
+            <a:ext cx="1737360" cy="868680"/>
+          </a:xfrm>
+          <a:prstGeom prst="rect">
+            <a:avLst/>
+          </a:prstGeom>
+          <a:noFill/>
+        </p:spPr>
+        <p:txBody>
+          <a:bodyPr wrap="none" lIns="0" rIns="0" tIns="0" bIns="0" anchor="ctr">
+            <a:spAutoFit/>
+          </a:bodyPr>
+          <a:lstStyle/>
+          <a:p>
+            <a:pPr algn="ctr">
+              <a:defRPr sz="1400" b="0">
+                <a:solidFill>
+                  <a:srgbClr val="263444"/>
+                </a:solidFill>
+                <a:latin typeface="Microsoft YaHei"/>
+              </a:defRPr>
+            </a:pPr>
+            <a:r>
+              <a:t>右侧 HC–EC</a:t>
+            </a:r>
+            <a:br/>
+            <a:r>
+              <a:t>iTBS / cTBS / control</a:t>
+            </a:r>
+          </a:p>
+        </p:txBody>
+      </p:sp>
+      <p:sp>
+        <p:nvSpPr>
+          <p:cNvPr id="12" name="TextBox 11"/>
+          <p:cNvSpPr txBox="1"/>
+          <p:nvPr/>
+        </p:nvSpPr>
+        <p:spPr>
+          <a:xfrm>
+            <a:off x="4864608" y="2724912"/>
+            <a:ext cx="365760" cy="320040"/>
+          </a:xfrm>
+          <a:prstGeom prst="rect">
+            <a:avLst/>
+          </a:prstGeom>
+          <a:noFill/>
+        </p:spPr>
+        <p:txBody>
+          <a:bodyPr wrap="none" lIns="0" rIns="0" tIns="0" bIns="0" anchor="ctr">
+            <a:spAutoFit/>
+          </a:bodyPr>
+          <a:lstStyle/>
+          <a:p>
+            <a:pPr algn="ctr">
+              <a:defRPr sz="2400" b="1">
+                <a:solidFill>
+                  <a:srgbClr val="5F7082"/>
+                </a:solidFill>
+                <a:latin typeface="Microsoft YaHei"/>
+              </a:defRPr>
+            </a:pPr>
+            <a:r>
+              <a:t>→</a:t>
+            </a:r>
+          </a:p>
+        </p:txBody>
+      </p:sp>
+      <p:sp>
+        <p:nvSpPr>
+          <p:cNvPr id="13" name="Rounded Rectangle 12"/>
+          <p:cNvSpPr/>
+          <p:nvPr/>
+        </p:nvSpPr>
+        <p:spPr>
+          <a:xfrm>
+            <a:off x="5221224" y="1965960"/>
+            <a:ext cx="1965960" cy="2057400"/>
+          </a:xfrm>
+          <a:prstGeom prst="roundRect">
+            <a:avLst/>
+          </a:prstGeom>
+          <a:solidFill>
+            <a:srgbClr val="FFFFFF"/>
+          </a:solidFill>
+          <a:ln w="25400">
+            <a:solidFill>
+              <a:srgbClr val="E5A93C"/>
+            </a:solidFill>
+          </a:ln>
+        </p:spPr>
+        <p:style>
+          <a:lnRef idx="1">
+            <a:schemeClr val="accent1"/>
+          </a:lnRef>
+          <a:fillRef idx="3">
+            <a:schemeClr val="accent1"/>
+          </a:fillRef>
+          <a:effectRef idx="2">
+            <a:schemeClr val="accent1"/>
+          </a:effectRef>
+          <a:fontRef idx="minor">
+            <a:schemeClr val="lt1"/>
+          </a:fontRef>
+        </p:style>
+        <p:txBody>
+          <a:bodyPr rtlCol="0" anchor="ctr"/>
+          <a:lstStyle/>
+          <a:p>
+            <a:pPr algn="ctr"/>
+          </a:p>
+        </p:txBody>
+      </p:sp>
+      <p:sp>
+        <p:nvSpPr>
+          <p:cNvPr id="14" name="TextBox 13"/>
+          <p:cNvSpPr txBox="1"/>
+          <p:nvPr/>
+        </p:nvSpPr>
+        <p:spPr>
+          <a:xfrm>
+            <a:off x="5330952" y="2176272"/>
+            <a:ext cx="1737360" cy="347472"/>
+          </a:xfrm>
+          <a:prstGeom prst="rect">
+            <a:avLst/>
+          </a:prstGeom>
+          <a:noFill/>
+        </p:spPr>
+        <p:txBody>
+          <a:bodyPr wrap="none" lIns="0" rIns="0" tIns="0" bIns="0" anchor="ctr">
+            <a:spAutoFit/>
+          </a:bodyPr>
+          <a:lstStyle/>
+          <a:p>
+            <a:pPr algn="ctr">
+              <a:defRPr sz="1500" b="1">
+                <a:solidFill>
+                  <a:srgbClr val="E5A93C"/>
+                </a:solidFill>
+                <a:latin typeface="Microsoft YaHei"/>
+              </a:defRPr>
+            </a:pPr>
+            <a:r>
+              <a:t>③ VR 任务</a:t>
+            </a:r>
+          </a:p>
+        </p:txBody>
+      </p:sp>
+      <p:sp>
+        <p:nvSpPr>
+          <p:cNvPr id="15" name="TextBox 14"/>
+          <p:cNvSpPr txBox="1"/>
+          <p:nvPr/>
+        </p:nvSpPr>
+        <p:spPr>
+          <a:xfrm>
+            <a:off x="5330952" y="2788920"/>
+            <a:ext cx="1737360" cy="868680"/>
+          </a:xfrm>
+          <a:prstGeom prst="rect">
+            <a:avLst/>
+          </a:prstGeom>
+          <a:noFill/>
+        </p:spPr>
+        <p:txBody>
+          <a:bodyPr wrap="none" lIns="0" rIns="0" tIns="0" bIns="0" anchor="ctr">
+            <a:spAutoFit/>
+          </a:bodyPr>
+          <a:lstStyle/>
+          <a:p>
+            <a:pPr algn="ctr">
+              <a:defRPr sz="1400" b="0">
+                <a:solidFill>
+                  <a:srgbClr val="263444"/>
+                </a:solidFill>
+                <a:latin typeface="Microsoft YaHei"/>
+              </a:defRPr>
+            </a:pPr>
+            <a:r>
+              <a:t>编码物体位置</a:t>
+            </a:r>
+            <a:br/>
+            <a:r>
+              <a:t>检索并导航</a:t>
+            </a:r>
+          </a:p>
+        </p:txBody>
+      </p:sp>
+      <p:sp>
+        <p:nvSpPr>
+          <p:cNvPr id="16" name="TextBox 15"/>
+          <p:cNvSpPr txBox="1"/>
+          <p:nvPr/>
+        </p:nvSpPr>
+        <p:spPr>
+          <a:xfrm>
+            <a:off x="7223760" y="2724912"/>
+            <a:ext cx="365760" cy="320040"/>
+          </a:xfrm>
+          <a:prstGeom prst="rect">
+            <a:avLst/>
+          </a:prstGeom>
+          <a:noFill/>
+        </p:spPr>
+        <p:txBody>
+          <a:bodyPr wrap="none" lIns="0" rIns="0" tIns="0" bIns="0" anchor="ctr">
+            <a:spAutoFit/>
+          </a:bodyPr>
+          <a:lstStyle/>
+          <a:p>
+            <a:pPr algn="ctr">
+              <a:defRPr sz="2400" b="1">
+                <a:solidFill>
+                  <a:srgbClr val="5F7082"/>
+                </a:solidFill>
+                <a:latin typeface="Microsoft YaHei"/>
+              </a:defRPr>
+            </a:pPr>
+            <a:r>
+              <a:t>→</a:t>
+            </a:r>
+          </a:p>
+        </p:txBody>
+      </p:sp>
+      <p:sp>
+        <p:nvSpPr>
+          <p:cNvPr id="17" name="Rounded Rectangle 16"/>
+          <p:cNvSpPr/>
+          <p:nvPr/>
+        </p:nvSpPr>
+        <p:spPr>
+          <a:xfrm>
+            <a:off x="7580376" y="1965960"/>
+            <a:ext cx="1965960" cy="2057400"/>
+          </a:xfrm>
+          <a:prstGeom prst="roundRect">
+            <a:avLst/>
+          </a:prstGeom>
+          <a:solidFill>
+            <a:srgbClr val="FFFFFF"/>
+          </a:solidFill>
+          <a:ln w="25400">
+            <a:solidFill>
+              <a:srgbClr val="142B4B"/>
+            </a:solidFill>
+          </a:ln>
+        </p:spPr>
+        <p:style>
+          <a:lnRef idx="1">
+            <a:schemeClr val="accent1"/>
+          </a:lnRef>
+          <a:fillRef idx="3">
+            <a:schemeClr val="accent1"/>
+          </a:fillRef>
+          <a:effectRef idx="2">
+            <a:schemeClr val="accent1"/>
+          </a:effectRef>
+          <a:fontRef idx="minor">
+            <a:schemeClr val="lt1"/>
+          </a:fontRef>
+        </p:style>
+        <p:txBody>
+          <a:bodyPr rtlCol="0" anchor="ctr"/>
+          <a:lstStyle/>
+          <a:p>
+            <a:pPr algn="ctr"/>
+          </a:p>
+        </p:txBody>
+      </p:sp>
+      <p:sp>
+        <p:nvSpPr>
+          <p:cNvPr id="18" name="TextBox 17"/>
+          <p:cNvSpPr txBox="1"/>
+          <p:nvPr/>
+        </p:nvSpPr>
+        <p:spPr>
+          <a:xfrm>
+            <a:off x="7690104" y="2176272"/>
+            <a:ext cx="1737360" cy="347472"/>
+          </a:xfrm>
+          <a:prstGeom prst="rect">
+            <a:avLst/>
+          </a:prstGeom>
+          <a:noFill/>
+        </p:spPr>
+        <p:txBody>
+          <a:bodyPr wrap="none" lIns="0" rIns="0" tIns="0" bIns="0" anchor="ctr">
+            <a:spAutoFit/>
+          </a:bodyPr>
+          <a:lstStyle/>
+          <a:p>
+            <a:pPr algn="ctr">
+              <a:defRPr sz="1500" b="1">
+                <a:solidFill>
+                  <a:srgbClr val="142B4B"/>
+                </a:solidFill>
+                <a:latin typeface="Microsoft YaHei"/>
+              </a:defRPr>
+            </a:pPr>
+            <a:r>
+              <a:t>④ MRI 测量</a:t>
+            </a:r>
+          </a:p>
+        </p:txBody>
+      </p:sp>
+      <p:sp>
+        <p:nvSpPr>
+          <p:cNvPr id="19" name="TextBox 18"/>
+          <p:cNvSpPr txBox="1"/>
+          <p:nvPr/>
+        </p:nvSpPr>
+        <p:spPr>
+          <a:xfrm>
+            <a:off x="7690104" y="2788920"/>
+            <a:ext cx="1737360" cy="868680"/>
+          </a:xfrm>
+          <a:prstGeom prst="rect">
+            <a:avLst/>
+          </a:prstGeom>
+          <a:noFill/>
+        </p:spPr>
+        <p:txBody>
+          <a:bodyPr wrap="none" lIns="0" rIns="0" tIns="0" bIns="0" anchor="ctr">
+            <a:spAutoFit/>
+          </a:bodyPr>
+          <a:lstStyle/>
+          <a:p>
+            <a:pPr algn="ctr">
+              <a:defRPr sz="1400" b="0">
+                <a:solidFill>
+                  <a:srgbClr val="263444"/>
+                </a:solidFill>
+                <a:latin typeface="Microsoft YaHei"/>
+              </a:defRPr>
+            </a:pPr>
+            <a:r>
+              <a:t>BOLD 活动</a:t>
+            </a:r>
+            <a:br/>
+            <a:r>
+              <a:t>GCLR 六重对称</a:t>
+            </a:r>
+          </a:p>
+        </p:txBody>
+      </p:sp>
+      <p:sp>
+        <p:nvSpPr>
+          <p:cNvPr id="20" name="TextBox 19"/>
+          <p:cNvSpPr txBox="1"/>
+          <p:nvPr/>
+        </p:nvSpPr>
+        <p:spPr>
+          <a:xfrm>
+            <a:off x="9582912" y="2724912"/>
+            <a:ext cx="365760" cy="320040"/>
+          </a:xfrm>
+          <a:prstGeom prst="rect">
+            <a:avLst/>
+          </a:prstGeom>
+          <a:noFill/>
+        </p:spPr>
+        <p:txBody>
+          <a:bodyPr wrap="none" lIns="0" rIns="0" tIns="0" bIns="0" anchor="ctr">
+            <a:spAutoFit/>
+          </a:bodyPr>
+          <a:lstStyle/>
+          <a:p>
+            <a:pPr algn="ctr">
+              <a:defRPr sz="2400" b="1">
+                <a:solidFill>
+                  <a:srgbClr val="5F7082"/>
+                </a:solidFill>
+                <a:latin typeface="Microsoft YaHei"/>
+              </a:defRPr>
+            </a:pPr>
+            <a:r>
+              <a:t>→</a:t>
+            </a:r>
+          </a:p>
+        </p:txBody>
+      </p:sp>
+      <p:sp>
+        <p:nvSpPr>
+          <p:cNvPr id="21" name="Rounded Rectangle 20"/>
+          <p:cNvSpPr/>
+          <p:nvPr/>
+        </p:nvSpPr>
+        <p:spPr>
+          <a:xfrm>
+            <a:off x="9939528" y="1965960"/>
+            <a:ext cx="1965960" cy="2057400"/>
+          </a:xfrm>
+          <a:prstGeom prst="roundRect">
+            <a:avLst/>
+          </a:prstGeom>
+          <a:solidFill>
+            <a:srgbClr val="FFFFFF"/>
+          </a:solidFill>
+          <a:ln w="25400">
+            <a:solidFill>
+              <a:srgbClr val="2A6EB4"/>
+            </a:solidFill>
+          </a:ln>
+        </p:spPr>
+        <p:style>
+          <a:lnRef idx="1">
+            <a:schemeClr val="accent1"/>
+          </a:lnRef>
+          <a:fillRef idx="3">
+            <a:schemeClr val="accent1"/>
+          </a:fillRef>
+          <a:effectRef idx="2">
+            <a:schemeClr val="accent1"/>
+          </a:effectRef>
+          <a:fontRef idx="minor">
+            <a:schemeClr val="lt1"/>
+          </a:fontRef>
+        </p:style>
+        <p:txBody>
+          <a:bodyPr rtlCol="0" anchor="ctr"/>
+          <a:lstStyle/>
+          <a:p>
+            <a:pPr algn="ctr"/>
+          </a:p>
+        </p:txBody>
+      </p:sp>
+      <p:sp>
+        <p:nvSpPr>
+          <p:cNvPr id="22" name="TextBox 21"/>
+          <p:cNvSpPr txBox="1"/>
+          <p:nvPr/>
+        </p:nvSpPr>
+        <p:spPr>
+          <a:xfrm>
+            <a:off x="10049256" y="2176272"/>
+            <a:ext cx="1737360" cy="347472"/>
+          </a:xfrm>
+          <a:prstGeom prst="rect">
+            <a:avLst/>
+          </a:prstGeom>
+          <a:noFill/>
+        </p:spPr>
+        <p:txBody>
+          <a:bodyPr wrap="none" lIns="0" rIns="0" tIns="0" bIns="0" anchor="ctr">
+            <a:spAutoFit/>
+          </a:bodyPr>
+          <a:lstStyle/>
+          <a:p>
+            <a:pPr algn="ctr">
+              <a:defRPr sz="1500" b="1">
+                <a:solidFill>
+                  <a:srgbClr val="2A6EB4"/>
+                </a:solidFill>
+                <a:latin typeface="Microsoft YaHei"/>
+              </a:defRPr>
+            </a:pPr>
+            <a:r>
+              <a:t>⑤ 结果</a:t>
+            </a:r>
+          </a:p>
+        </p:txBody>
+      </p:sp>
+      <p:sp>
+        <p:nvSpPr>
+          <p:cNvPr id="23" name="TextBox 22"/>
+          <p:cNvSpPr txBox="1"/>
+          <p:nvPr/>
+        </p:nvSpPr>
+        <p:spPr>
+          <a:xfrm>
+            <a:off x="10049256" y="2788920"/>
+            <a:ext cx="1737360" cy="868680"/>
+          </a:xfrm>
+          <a:prstGeom prst="rect">
+            <a:avLst/>
+          </a:prstGeom>
+          <a:noFill/>
+        </p:spPr>
+        <p:txBody>
+          <a:bodyPr wrap="none" lIns="0" rIns="0" tIns="0" bIns="0" anchor="ctr">
+            <a:spAutoFit/>
+          </a:bodyPr>
+          <a:lstStyle/>
+          <a:p>
+            <a:pPr algn="ctr">
+              <a:defRPr sz="1400" b="0">
+                <a:solidFill>
+                  <a:srgbClr val="263444"/>
+                </a:solidFill>
+                <a:latin typeface="Microsoft YaHei"/>
+              </a:defRPr>
+            </a:pPr>
+            <a:r>
+              <a:t>行为效率↑</a:t>
+            </a:r>
+            <a:br/>
+            <a:r>
+              <a:t>HC 活动改变</a:t>
+            </a:r>
+            <a:br/>
+            <a:r>
+              <a:t>GCLR↓</a:t>
+            </a:r>
+          </a:p>
+        </p:txBody>
+      </p:sp>
+      <p:sp>
+        <p:nvSpPr>
+          <p:cNvPr id="24" name="Rounded Rectangle 23"/>
+          <p:cNvSpPr/>
+          <p:nvPr/>
+        </p:nvSpPr>
+        <p:spPr>
+          <a:xfrm>
+            <a:off x="1005840" y="4800600"/>
+            <a:ext cx="10149840" cy="960120"/>
+          </a:xfrm>
+          <a:prstGeom prst="roundRect">
+            <a:avLst/>
+          </a:prstGeom>
+          <a:solidFill>
+            <a:srgbClr val="E8F2F9"/>
+          </a:solidFill>
+          <a:ln>
+            <a:solidFill>
+              <a:srgbClr val="C1D8E7"/>
+            </a:solidFill>
+          </a:ln>
+        </p:spPr>
+        <p:style>
+          <a:lnRef idx="1">
+            <a:schemeClr val="accent1"/>
+          </a:lnRef>
+          <a:fillRef idx="3">
+            <a:schemeClr val="accent1"/>
+          </a:fillRef>
+          <a:effectRef idx="2">
+            <a:schemeClr val="accent1"/>
+          </a:effectRef>
+          <a:fontRef idx="minor">
+            <a:schemeClr val="lt1"/>
+          </a:fontRef>
+        </p:style>
+        <p:txBody>
+          <a:bodyPr rtlCol="0" anchor="ctr"/>
+          <a:lstStyle/>
+          <a:p>
+            <a:pPr algn="ctr"/>
+          </a:p>
+        </p:txBody>
+      </p:sp>
+      <p:sp>
+        <p:nvSpPr>
+          <p:cNvPr id="25" name="TextBox 24"/>
+          <p:cNvSpPr txBox="1"/>
+          <p:nvPr/>
+        </p:nvSpPr>
+        <p:spPr>
+          <a:xfrm>
+            <a:off x="1234440" y="5010912"/>
+            <a:ext cx="9692640" cy="475488"/>
+          </a:xfrm>
+          <a:prstGeom prst="rect">
+            <a:avLst/>
+          </a:prstGeom>
+          <a:noFill/>
+        </p:spPr>
+        <p:txBody>
+          <a:bodyPr wrap="none" lIns="0" rIns="0" tIns="0" bIns="0" anchor="ctr">
+            <a:spAutoFit/>
+          </a:bodyPr>
+          <a:lstStyle/>
+          <a:p>
+            <a:pPr algn="ctr">
+              <a:defRPr sz="1600" b="1">
+                <a:solidFill>
+                  <a:srgbClr val="142B4B"/>
+                </a:solidFill>
+                <a:latin typeface="Microsoft YaHei"/>
+              </a:defRPr>
+            </a:pPr>
+            <a:r>
+              <a:t>核心逻辑：tTIS 改变 HC–EC 活动 → 影响空间记忆提取速度 → 同步改变海马活动与内嗅皮层网格细胞样表征。</a:t>
             </a:r>
           </a:p>
         </p:txBody>

</xml_diff>